<commit_message>
feat: adiciona prints das telas do aplicativo na apresentacao SINTEC 2026
</commit_message>
<xml_diff>
--- a/Apresentacao-SINTEC-2026-Equinox-Mobile.pptx
+++ b/Apresentacao-SINTEC-2026-Equinox-Mobile.pptx
@@ -20638,58 +20638,20 @@
           </a:p>
         </p:txBody>
       </p:sp>
-      <p:sp>
-        <p:nvSpPr>
-          <p:cNvPr id="21" name="Rounded Rectangle 20"/>
-          <p:cNvSpPr/>
-          <p:nvPr/>
-        </p:nvSpPr>
-        <p:spPr>
-          <a:xfrm>
-            <a:off x="1508760" y="2746400"/>
-            <a:ext cx="685800" cy="53126"/>
-          </a:xfrm>
-          <a:prstGeom prst="roundRect">
-            <a:avLst>
-              <a:gd name="adj" fmla="val 50000"/>
-            </a:avLst>
-          </a:prstGeom>
-          <a:solidFill>
-            <a:srgbClr val="1E293B"/>
-          </a:solidFill>
-          <a:ln>
-            <a:noFill/>
-          </a:ln>
-          <a:effectLst/>
-        </p:spPr>
-        <p:style>
-          <a:lnRef idx="1">
-            <a:schemeClr val="accent1"/>
-          </a:lnRef>
-          <a:fillRef idx="3">
-            <a:schemeClr val="accent1"/>
-          </a:fillRef>
-          <a:effectRef idx="2">
-            <a:schemeClr val="accent1"/>
-          </a:effectRef>
-          <a:fontRef idx="minor">
-            <a:schemeClr val="lt1"/>
-          </a:fontRef>
-        </p:style>
-        <p:txBody>
-          <a:bodyPr rtlCol="0" anchor="ctr"/>
-          <a:lstStyle/>
-          <a:p>
-            <a:pPr algn="ctr"/>
-          </a:p>
-        </p:txBody>
-      </p:sp>
-      <p:sp>
-        <p:nvSpPr>
-          <p:cNvPr id="22" name="TextBox 21"/>
-          <p:cNvSpPr txBox="1"/>
-          <p:nvPr/>
-        </p:nvSpPr>
+      <p:pic>
+        <p:nvPicPr>
+          <p:cNvPr id="21" name="Picture 20" descr="print_01_login.png"/>
+          <p:cNvPicPr>
+            <a:picLocks noChangeAspect="1"/>
+          </p:cNvPicPr>
+          <p:nvPr/>
+        </p:nvPicPr>
+        <p:blipFill>
+          <a:blip r:embed="rId3"/>
+          <a:stretch>
+            <a:fillRect/>
+          </a:stretch>
+        </p:blipFill>
         <p:spPr>
           <a:xfrm>
             <a:off x="960120" y="2670505"/>
@@ -20698,53 +20660,11 @@
           <a:prstGeom prst="rect">
             <a:avLst/>
           </a:prstGeom>
-          <a:noFill/>
-        </p:spPr>
-        <p:txBody>
-          <a:bodyPr wrap="square" anchor="ctr" lIns="0" rIns="0" tIns="0" bIns="0">
-            <a:spAutoFit/>
-          </a:bodyPr>
-          <a:lstStyle/>
-          <a:p>
-            <a:pPr algn="ctr">
-              <a:lnSpc>
-                <a:spcPct val="110000"/>
-              </a:lnSpc>
-            </a:pPr>
-            <a:r>
-              <a:rPr sz="1150" b="1">
-                <a:solidFill>
-                  <a:srgbClr val="34D399"/>
-                </a:solidFill>
-                <a:latin typeface="Consolas"/>
-              </a:rPr>
-              <a:t>INSERIR PRINT</a:t>
-            </a:r>
-          </a:p>
-          <a:p>
-            <a:pPr algn="ctr">
-              <a:lnSpc>
-                <a:spcPct val="110000"/>
-              </a:lnSpc>
-              <a:spcBef>
-                <a:spcPts val="0"/>
-              </a:spcBef>
-            </a:pPr>
-            <a:r>
-              <a:rPr sz="1150" b="0">
-                <a:solidFill>
-                  <a:srgbClr val="94A3B8"/>
-                </a:solidFill>
-                <a:latin typeface="Consolas"/>
-              </a:rPr>
-              <a:t>da tela</a:t>
-            </a:r>
-          </a:p>
-        </p:txBody>
-      </p:sp>
-      <p:sp>
-        <p:nvSpPr>
-          <p:cNvPr id="23" name="TextBox 22"/>
+        </p:spPr>
+      </p:pic>
+      <p:sp>
+        <p:nvSpPr>
+          <p:cNvPr id="22" name="TextBox 21"/>
           <p:cNvSpPr txBox="1"/>
           <p:nvPr/>
         </p:nvSpPr>
@@ -20783,7 +20703,7 @@
       </p:sp>
       <p:sp>
         <p:nvSpPr>
-          <p:cNvPr id="24" name="Rounded Rectangle 23"/>
+          <p:cNvPr id="23" name="Rounded Rectangle 22"/>
           <p:cNvSpPr/>
           <p:nvPr/>
         </p:nvSpPr>
@@ -20829,58 +20749,20 @@
           </a:p>
         </p:txBody>
       </p:sp>
-      <p:sp>
-        <p:nvSpPr>
-          <p:cNvPr id="25" name="Rounded Rectangle 24"/>
-          <p:cNvSpPr/>
-          <p:nvPr/>
-        </p:nvSpPr>
-        <p:spPr>
-          <a:xfrm>
-            <a:off x="4315968" y="2746400"/>
-            <a:ext cx="685800" cy="53126"/>
-          </a:xfrm>
-          <a:prstGeom prst="roundRect">
-            <a:avLst>
-              <a:gd name="adj" fmla="val 50000"/>
-            </a:avLst>
-          </a:prstGeom>
-          <a:solidFill>
-            <a:srgbClr val="1E293B"/>
-          </a:solidFill>
-          <a:ln>
-            <a:noFill/>
-          </a:ln>
-          <a:effectLst/>
-        </p:spPr>
-        <p:style>
-          <a:lnRef idx="1">
-            <a:schemeClr val="accent1"/>
-          </a:lnRef>
-          <a:fillRef idx="3">
-            <a:schemeClr val="accent1"/>
-          </a:fillRef>
-          <a:effectRef idx="2">
-            <a:schemeClr val="accent1"/>
-          </a:effectRef>
-          <a:fontRef idx="minor">
-            <a:schemeClr val="lt1"/>
-          </a:fontRef>
-        </p:style>
-        <p:txBody>
-          <a:bodyPr rtlCol="0" anchor="ctr"/>
-          <a:lstStyle/>
-          <a:p>
-            <a:pPr algn="ctr"/>
-          </a:p>
-        </p:txBody>
-      </p:sp>
-      <p:sp>
-        <p:nvSpPr>
-          <p:cNvPr id="26" name="TextBox 25"/>
-          <p:cNvSpPr txBox="1"/>
-          <p:nvPr/>
-        </p:nvSpPr>
+      <p:pic>
+        <p:nvPicPr>
+          <p:cNvPr id="24" name="Picture 23" descr="print_02_usuario.png"/>
+          <p:cNvPicPr>
+            <a:picLocks noChangeAspect="1"/>
+          </p:cNvPicPr>
+          <p:nvPr/>
+        </p:nvPicPr>
+        <p:blipFill>
+          <a:blip r:embed="rId4"/>
+          <a:stretch>
+            <a:fillRect/>
+          </a:stretch>
+        </p:blipFill>
         <p:spPr>
           <a:xfrm>
             <a:off x="3767328" y="2670505"/>
@@ -20889,53 +20771,11 @@
           <a:prstGeom prst="rect">
             <a:avLst/>
           </a:prstGeom>
-          <a:noFill/>
-        </p:spPr>
-        <p:txBody>
-          <a:bodyPr wrap="square" anchor="ctr" lIns="0" rIns="0" tIns="0" bIns="0">
-            <a:spAutoFit/>
-          </a:bodyPr>
-          <a:lstStyle/>
-          <a:p>
-            <a:pPr algn="ctr">
-              <a:lnSpc>
-                <a:spcPct val="110000"/>
-              </a:lnSpc>
-            </a:pPr>
-            <a:r>
-              <a:rPr sz="1150" b="1">
-                <a:solidFill>
-                  <a:srgbClr val="60A5FA"/>
-                </a:solidFill>
-                <a:latin typeface="Consolas"/>
-              </a:rPr>
-              <a:t>INSERIR PRINT</a:t>
-            </a:r>
-          </a:p>
-          <a:p>
-            <a:pPr algn="ctr">
-              <a:lnSpc>
-                <a:spcPct val="110000"/>
-              </a:lnSpc>
-              <a:spcBef>
-                <a:spcPts val="0"/>
-              </a:spcBef>
-            </a:pPr>
-            <a:r>
-              <a:rPr sz="1150" b="0">
-                <a:solidFill>
-                  <a:srgbClr val="94A3B8"/>
-                </a:solidFill>
-                <a:latin typeface="Consolas"/>
-              </a:rPr>
-              <a:t>da tela</a:t>
-            </a:r>
-          </a:p>
-        </p:txBody>
-      </p:sp>
-      <p:sp>
-        <p:nvSpPr>
-          <p:cNvPr id="27" name="TextBox 26"/>
+        </p:spPr>
+      </p:pic>
+      <p:sp>
+        <p:nvSpPr>
+          <p:cNvPr id="25" name="TextBox 24"/>
           <p:cNvSpPr txBox="1"/>
           <p:nvPr/>
         </p:nvSpPr>
@@ -20967,14 +20807,14 @@
                 </a:solidFill>
                 <a:latin typeface="Segoe UI"/>
               </a:rPr>
-              <a:t>Painel / Dashboard</a:t>
+              <a:t>Painel Usuário</a:t>
             </a:r>
           </a:p>
         </p:txBody>
       </p:sp>
       <p:sp>
         <p:nvSpPr>
-          <p:cNvPr id="28" name="Rounded Rectangle 27"/>
+          <p:cNvPr id="26" name="Rounded Rectangle 25"/>
           <p:cNvSpPr/>
           <p:nvPr/>
         </p:nvSpPr>
@@ -21020,58 +20860,20 @@
           </a:p>
         </p:txBody>
       </p:sp>
-      <p:sp>
-        <p:nvSpPr>
-          <p:cNvPr id="29" name="Rounded Rectangle 28"/>
-          <p:cNvSpPr/>
-          <p:nvPr/>
-        </p:nvSpPr>
-        <p:spPr>
-          <a:xfrm>
-            <a:off x="7123175" y="2746400"/>
-            <a:ext cx="685800" cy="53126"/>
-          </a:xfrm>
-          <a:prstGeom prst="roundRect">
-            <a:avLst>
-              <a:gd name="adj" fmla="val 50000"/>
-            </a:avLst>
-          </a:prstGeom>
-          <a:solidFill>
-            <a:srgbClr val="1E293B"/>
-          </a:solidFill>
-          <a:ln>
-            <a:noFill/>
-          </a:ln>
-          <a:effectLst/>
-        </p:spPr>
-        <p:style>
-          <a:lnRef idx="1">
-            <a:schemeClr val="accent1"/>
-          </a:lnRef>
-          <a:fillRef idx="3">
-            <a:schemeClr val="accent1"/>
-          </a:fillRef>
-          <a:effectRef idx="2">
-            <a:schemeClr val="accent1"/>
-          </a:effectRef>
-          <a:fontRef idx="minor">
-            <a:schemeClr val="lt1"/>
-          </a:fontRef>
-        </p:style>
-        <p:txBody>
-          <a:bodyPr rtlCol="0" anchor="ctr"/>
-          <a:lstStyle/>
-          <a:p>
-            <a:pPr algn="ctr"/>
-          </a:p>
-        </p:txBody>
-      </p:sp>
-      <p:sp>
-        <p:nvSpPr>
-          <p:cNvPr id="30" name="TextBox 29"/>
-          <p:cNvSpPr txBox="1"/>
-          <p:nvPr/>
-        </p:nvSpPr>
+      <p:pic>
+        <p:nvPicPr>
+          <p:cNvPr id="27" name="Picture 26" descr="print_03_admin.png"/>
+          <p:cNvPicPr>
+            <a:picLocks noChangeAspect="1"/>
+          </p:cNvPicPr>
+          <p:nvPr/>
+        </p:nvPicPr>
+        <p:blipFill>
+          <a:blip r:embed="rId5"/>
+          <a:stretch>
+            <a:fillRect/>
+          </a:stretch>
+        </p:blipFill>
         <p:spPr>
           <a:xfrm>
             <a:off x="6574536" y="2670505"/>
@@ -21080,53 +20882,11 @@
           <a:prstGeom prst="rect">
             <a:avLst/>
           </a:prstGeom>
-          <a:noFill/>
-        </p:spPr>
-        <p:txBody>
-          <a:bodyPr wrap="square" anchor="ctr" lIns="0" rIns="0" tIns="0" bIns="0">
-            <a:spAutoFit/>
-          </a:bodyPr>
-          <a:lstStyle/>
-          <a:p>
-            <a:pPr algn="ctr">
-              <a:lnSpc>
-                <a:spcPct val="110000"/>
-              </a:lnSpc>
-            </a:pPr>
-            <a:r>
-              <a:rPr sz="1150" b="1">
-                <a:solidFill>
-                  <a:srgbClr val="FB923C"/>
-                </a:solidFill>
-                <a:latin typeface="Consolas"/>
-              </a:rPr>
-              <a:t>INSERIR PRINT</a:t>
-            </a:r>
-          </a:p>
-          <a:p>
-            <a:pPr algn="ctr">
-              <a:lnSpc>
-                <a:spcPct val="110000"/>
-              </a:lnSpc>
-              <a:spcBef>
-                <a:spcPts val="0"/>
-              </a:spcBef>
-            </a:pPr>
-            <a:r>
-              <a:rPr sz="1150" b="0">
-                <a:solidFill>
-                  <a:srgbClr val="94A3B8"/>
-                </a:solidFill>
-                <a:latin typeface="Consolas"/>
-              </a:rPr>
-              <a:t>da tela</a:t>
-            </a:r>
-          </a:p>
-        </p:txBody>
-      </p:sp>
-      <p:sp>
-        <p:nvSpPr>
-          <p:cNvPr id="31" name="TextBox 30"/>
+        </p:spPr>
+      </p:pic>
+      <p:sp>
+        <p:nvSpPr>
+          <p:cNvPr id="28" name="TextBox 27"/>
           <p:cNvSpPr txBox="1"/>
           <p:nvPr/>
         </p:nvSpPr>
@@ -21158,14 +20918,14 @@
                 </a:solidFill>
                 <a:latin typeface="Segoe UI"/>
               </a:rPr>
-              <a:t>Nova leitura (câmera + GPS)</a:t>
+              <a:t>Painel Administrador</a:t>
             </a:r>
           </a:p>
         </p:txBody>
       </p:sp>
       <p:sp>
         <p:nvSpPr>
-          <p:cNvPr id="32" name="Rounded Rectangle 31"/>
+          <p:cNvPr id="29" name="Rounded Rectangle 28"/>
           <p:cNvSpPr/>
           <p:nvPr/>
         </p:nvSpPr>
@@ -21211,58 +20971,20 @@
           </a:p>
         </p:txBody>
       </p:sp>
-      <p:sp>
-        <p:nvSpPr>
-          <p:cNvPr id="33" name="Rounded Rectangle 32"/>
-          <p:cNvSpPr/>
-          <p:nvPr/>
-        </p:nvSpPr>
-        <p:spPr>
-          <a:xfrm>
-            <a:off x="9930384" y="2746400"/>
-            <a:ext cx="685800" cy="53126"/>
-          </a:xfrm>
-          <a:prstGeom prst="roundRect">
-            <a:avLst>
-              <a:gd name="adj" fmla="val 50000"/>
-            </a:avLst>
-          </a:prstGeom>
-          <a:solidFill>
-            <a:srgbClr val="1E293B"/>
-          </a:solidFill>
-          <a:ln>
-            <a:noFill/>
-          </a:ln>
-          <a:effectLst/>
-        </p:spPr>
-        <p:style>
-          <a:lnRef idx="1">
-            <a:schemeClr val="accent1"/>
-          </a:lnRef>
-          <a:fillRef idx="3">
-            <a:schemeClr val="accent1"/>
-          </a:fillRef>
-          <a:effectRef idx="2">
-            <a:schemeClr val="accent1"/>
-          </a:effectRef>
-          <a:fontRef idx="minor">
-            <a:schemeClr val="lt1"/>
-          </a:fontRef>
-        </p:style>
-        <p:txBody>
-          <a:bodyPr rtlCol="0" anchor="ctr"/>
-          <a:lstStyle/>
-          <a:p>
-            <a:pPr algn="ctr"/>
-          </a:p>
-        </p:txBody>
-      </p:sp>
-      <p:sp>
-        <p:nvSpPr>
-          <p:cNvPr id="34" name="TextBox 33"/>
-          <p:cNvSpPr txBox="1"/>
-          <p:nvPr/>
-        </p:nvSpPr>
+      <p:pic>
+        <p:nvPicPr>
+          <p:cNvPr id="30" name="Picture 29" descr="print_04_superadmin.png"/>
+          <p:cNvPicPr>
+            <a:picLocks noChangeAspect="1"/>
+          </p:cNvPicPr>
+          <p:nvPr/>
+        </p:nvPicPr>
+        <p:blipFill>
+          <a:blip r:embed="rId6"/>
+          <a:stretch>
+            <a:fillRect/>
+          </a:stretch>
+        </p:blipFill>
         <p:spPr>
           <a:xfrm>
             <a:off x="9381743" y="2670505"/>
@@ -21271,53 +20993,11 @@
           <a:prstGeom prst="rect">
             <a:avLst/>
           </a:prstGeom>
-          <a:noFill/>
-        </p:spPr>
-        <p:txBody>
-          <a:bodyPr wrap="square" anchor="ctr" lIns="0" rIns="0" tIns="0" bIns="0">
-            <a:spAutoFit/>
-          </a:bodyPr>
-          <a:lstStyle/>
-          <a:p>
-            <a:pPr algn="ctr">
-              <a:lnSpc>
-                <a:spcPct val="110000"/>
-              </a:lnSpc>
-            </a:pPr>
-            <a:r>
-              <a:rPr sz="1150" b="1">
-                <a:solidFill>
-                  <a:srgbClr val="A78BFA"/>
-                </a:solidFill>
-                <a:latin typeface="Consolas"/>
-              </a:rPr>
-              <a:t>INSERIR PRINT</a:t>
-            </a:r>
-          </a:p>
-          <a:p>
-            <a:pPr algn="ctr">
-              <a:lnSpc>
-                <a:spcPct val="110000"/>
-              </a:lnSpc>
-              <a:spcBef>
-                <a:spcPts val="0"/>
-              </a:spcBef>
-            </a:pPr>
-            <a:r>
-              <a:rPr sz="1150" b="0">
-                <a:solidFill>
-                  <a:srgbClr val="94A3B8"/>
-                </a:solidFill>
-                <a:latin typeface="Consolas"/>
-              </a:rPr>
-              <a:t>da tela</a:t>
-            </a:r>
-          </a:p>
-        </p:txBody>
-      </p:sp>
-      <p:sp>
-        <p:nvSpPr>
-          <p:cNvPr id="35" name="TextBox 34"/>
+        </p:spPr>
+      </p:pic>
+      <p:sp>
+        <p:nvSpPr>
+          <p:cNvPr id="31" name="TextBox 30"/>
           <p:cNvSpPr txBox="1"/>
           <p:nvPr/>
         </p:nvSpPr>
@@ -21349,14 +21029,14 @@
                 </a:solidFill>
                 <a:latin typeface="Segoe UI"/>
               </a:rPr>
-              <a:t>Administração</a:t>
+              <a:t>Super Administrador</a:t>
             </a:r>
           </a:p>
         </p:txBody>
       </p:sp>
       <p:sp>
         <p:nvSpPr>
-          <p:cNvPr id="36" name="Rectangle 35"/>
+          <p:cNvPr id="32" name="Rectangle 31"/>
           <p:cNvSpPr/>
           <p:nvPr/>
         </p:nvSpPr>
@@ -21400,7 +21080,7 @@
       </p:sp>
       <p:sp>
         <p:nvSpPr>
-          <p:cNvPr id="37" name="Rectangle 36"/>
+          <p:cNvPr id="33" name="Rectangle 32"/>
           <p:cNvSpPr/>
           <p:nvPr/>
         </p:nvSpPr>
@@ -21444,7 +21124,7 @@
       </p:sp>
       <p:sp>
         <p:nvSpPr>
-          <p:cNvPr id="38" name="Rectangle 37"/>
+          <p:cNvPr id="34" name="Rectangle 33"/>
           <p:cNvSpPr/>
           <p:nvPr/>
         </p:nvSpPr>
@@ -21488,7 +21168,7 @@
       </p:sp>
       <p:sp>
         <p:nvSpPr>
-          <p:cNvPr id="39" name="Rectangle 38"/>
+          <p:cNvPr id="35" name="Rectangle 34"/>
           <p:cNvSpPr/>
           <p:nvPr/>
         </p:nvSpPr>
@@ -21532,7 +21212,7 @@
       </p:sp>
       <p:sp>
         <p:nvSpPr>
-          <p:cNvPr id="40" name="Rectangle 39"/>
+          <p:cNvPr id="36" name="Rectangle 35"/>
           <p:cNvSpPr/>
           <p:nvPr/>
         </p:nvSpPr>
@@ -21576,7 +21256,7 @@
       </p:sp>
       <p:sp>
         <p:nvSpPr>
-          <p:cNvPr id="41" name="Rectangle 40"/>
+          <p:cNvPr id="37" name="Rectangle 36"/>
           <p:cNvSpPr/>
           <p:nvPr/>
         </p:nvSpPr>

</xml_diff>